<commit_message>
Center Closing layouts in two templates
</commit_message>
<xml_diff>
--- a/templates/forest-green.pptx
+++ b/templates/forest-green.pptx
@@ -546,8 +546,8 @@
         </p:nvSpPr>
         <p:spPr>
           <a:xfrm>
-            <a:off x="1485900" y="685800"/>
-            <a:ext cx="9486900" cy="1851025"/>
+            <a:off x="1524000" y="1122363"/>
+            <a:ext cx="9144000" cy="2387600"/>
           </a:xfrm>
         </p:spPr>
         <p:txBody>
@@ -580,8 +580,8 @@
         </p:nvSpPr>
         <p:spPr>
           <a:xfrm>
-            <a:off x="1485900" y="2667000"/>
-            <a:ext cx="9486900" cy="1371600"/>
+            <a:off x="1524000" y="3602038"/>
+            <a:ext cx="9144000" cy="1655762"/>
           </a:xfrm>
         </p:spPr>
         <p:txBody>

</xml_diff>